<commit_message>
Updated notes till ISE
</commit_message>
<xml_diff>
--- a/Sem 4/RDBMS/Mod 3/3.1 RelAlgebra_Join.pptx
+++ b/Sem 4/RDBMS/Mod 3/3.1 RelAlgebra_Join.pptx
@@ -15741,10 +15741,13 @@
               <a:buChar char="■"/>
             </a:pPr>
             <a:r>
-              <a:rPr lang="en-US" sz="2400" b="0" i="0" u="none">
+              <a:rPr lang="en-US" sz="2400" b="0" i="0" u="none" dirty="0">
                 <a:solidFill>
                   <a:schemeClr val="dk2"/>
                 </a:solidFill>
+                <a:highlight>
+                  <a:srgbClr val="FFFF00"/>
+                </a:highlight>
                 <a:latin typeface="Arial"/>
                 <a:ea typeface="Arial"/>
                 <a:cs typeface="Arial"/>
@@ -15752,7 +15755,11 @@
               </a:rPr>
               <a:t>The OUTER JOIN Operation</a:t>
             </a:r>
-            <a:endParaRPr/>
+            <a:endParaRPr dirty="0">
+              <a:highlight>
+                <a:srgbClr val="FFFF00"/>
+              </a:highlight>
+            </a:endParaRPr>
           </a:p>
           <a:p>
             <a:pPr marL="742950" lvl="1" indent="-285750" algn="l" rtl="0">
@@ -15773,10 +15780,13 @@
               <a:buChar char="■"/>
             </a:pPr>
             <a:r>
-              <a:rPr lang="en-US" sz="2200" b="0" i="0" u="none">
+              <a:rPr lang="en-US" sz="2200" b="0" i="0" u="none" dirty="0">
                 <a:solidFill>
                   <a:srgbClr val="800000"/>
                 </a:solidFill>
+                <a:highlight>
+                  <a:srgbClr val="FFFF00"/>
+                </a:highlight>
                 <a:latin typeface="Arial"/>
                 <a:ea typeface="Arial"/>
                 <a:cs typeface="Arial"/>
@@ -15785,10 +15795,13 @@
               <a:t>In NATURAL JOIN and EQUIJOIN, tuples without a </a:t>
             </a:r>
             <a:r>
-              <a:rPr lang="en-US" sz="2200" b="0" i="1" u="none">
+              <a:rPr lang="en-US" sz="2200" b="0" i="1" u="none" dirty="0">
                 <a:solidFill>
                   <a:srgbClr val="800000"/>
                 </a:solidFill>
+                <a:highlight>
+                  <a:srgbClr val="FFFF00"/>
+                </a:highlight>
                 <a:latin typeface="Arial"/>
                 <a:ea typeface="Arial"/>
                 <a:cs typeface="Arial"/>
@@ -15797,10 +15810,13 @@
               <a:t>matching</a:t>
             </a:r>
             <a:r>
-              <a:rPr lang="en-US" sz="2200" b="0" i="0" u="none">
+              <a:rPr lang="en-US" sz="2200" b="0" i="0" u="none" dirty="0">
                 <a:solidFill>
                   <a:srgbClr val="800000"/>
                 </a:solidFill>
+                <a:highlight>
+                  <a:srgbClr val="FFFF00"/>
+                </a:highlight>
                 <a:latin typeface="Arial"/>
                 <a:ea typeface="Arial"/>
                 <a:cs typeface="Arial"/>
@@ -15809,10 +15825,13 @@
               <a:t> (or </a:t>
             </a:r>
             <a:r>
-              <a:rPr lang="en-US" sz="2200" b="0" i="1" u="none">
+              <a:rPr lang="en-US" sz="2200" b="0" i="1" u="none" dirty="0">
                 <a:solidFill>
                   <a:srgbClr val="800000"/>
                 </a:solidFill>
+                <a:highlight>
+                  <a:srgbClr val="FFFF00"/>
+                </a:highlight>
                 <a:latin typeface="Arial"/>
                 <a:ea typeface="Arial"/>
                 <a:cs typeface="Arial"/>
@@ -15821,10 +15840,13 @@
               <a:t>related</a:t>
             </a:r>
             <a:r>
-              <a:rPr lang="en-US" sz="2200" b="0" i="0" u="none">
+              <a:rPr lang="en-US" sz="2200" b="0" i="0" u="none" dirty="0">
                 <a:solidFill>
                   <a:srgbClr val="800000"/>
                 </a:solidFill>
+                <a:highlight>
+                  <a:srgbClr val="FFFF00"/>
+                </a:highlight>
                 <a:latin typeface="Arial"/>
                 <a:ea typeface="Arial"/>
                 <a:cs typeface="Arial"/>
@@ -15832,7 +15854,11 @@
               </a:rPr>
               <a:t>) tuple are eliminated from the join result</a:t>
             </a:r>
-            <a:endParaRPr/>
+            <a:endParaRPr dirty="0">
+              <a:highlight>
+                <a:srgbClr val="FFFF00"/>
+              </a:highlight>
+            </a:endParaRPr>
           </a:p>
           <a:p>
             <a:pPr marL="1143000" lvl="2" indent="-228600" algn="l" rtl="0">
@@ -15853,10 +15879,13 @@
               <a:buChar char="■"/>
             </a:pPr>
             <a:r>
-              <a:rPr lang="en-US" sz="2000" b="0" i="0" u="none">
+              <a:rPr lang="en-US" sz="2000" b="0" i="0" u="none" dirty="0">
                 <a:solidFill>
                   <a:schemeClr val="dk2"/>
                 </a:solidFill>
+                <a:highlight>
+                  <a:srgbClr val="FFFF00"/>
+                </a:highlight>
                 <a:latin typeface="Arial"/>
                 <a:ea typeface="Arial"/>
                 <a:cs typeface="Arial"/>
@@ -15864,7 +15893,11 @@
               </a:rPr>
               <a:t>Tuples with null in the join attributes are also eliminated</a:t>
             </a:r>
-            <a:endParaRPr/>
+            <a:endParaRPr dirty="0">
+              <a:highlight>
+                <a:srgbClr val="FFFF00"/>
+              </a:highlight>
+            </a:endParaRPr>
           </a:p>
           <a:p>
             <a:pPr marL="1143000" lvl="2" indent="-228600" algn="l" rtl="0">
@@ -15885,10 +15918,13 @@
               <a:buChar char="■"/>
             </a:pPr>
             <a:r>
-              <a:rPr lang="en-US" sz="2000" b="0" i="0" u="none">
+              <a:rPr lang="en-US" sz="2000" b="0" i="0" u="none" dirty="0">
                 <a:solidFill>
                   <a:schemeClr val="dk2"/>
                 </a:solidFill>
+                <a:highlight>
+                  <a:srgbClr val="FFFF00"/>
+                </a:highlight>
                 <a:latin typeface="Arial"/>
                 <a:ea typeface="Arial"/>
                 <a:cs typeface="Arial"/>
@@ -15896,7 +15932,11 @@
               </a:rPr>
               <a:t>This amounts to loss of information.</a:t>
             </a:r>
-            <a:endParaRPr/>
+            <a:endParaRPr dirty="0">
+              <a:highlight>
+                <a:srgbClr val="FFFF00"/>
+              </a:highlight>
+            </a:endParaRPr>
           </a:p>
           <a:p>
             <a:pPr marL="742950" lvl="1" indent="-285750" algn="l" rtl="0">
@@ -15917,10 +15957,13 @@
               <a:buChar char="■"/>
             </a:pPr>
             <a:r>
-              <a:rPr lang="en-US" sz="2200" b="0" i="0" u="none">
+              <a:rPr lang="en-US" sz="2200" b="0" i="0" u="none" dirty="0">
                 <a:solidFill>
                   <a:srgbClr val="800000"/>
                 </a:solidFill>
+                <a:highlight>
+                  <a:srgbClr val="FFFF00"/>
+                </a:highlight>
                 <a:latin typeface="Arial"/>
                 <a:ea typeface="Arial"/>
                 <a:cs typeface="Arial"/>
@@ -15928,7 +15971,11 @@
               </a:rPr>
               <a:t>A set of operations, called OUTER joins, can be used when we want to keep all the tuples in R, or all those in S, or all those in both relations in the result of the join, regardless of whether or not they have matching tuples in the other relation.</a:t>
             </a:r>
-            <a:endParaRPr/>
+            <a:endParaRPr dirty="0">
+              <a:highlight>
+                <a:srgbClr val="FFFF00"/>
+              </a:highlight>
+            </a:endParaRPr>
           </a:p>
         </p:txBody>
       </p:sp>

</xml_diff>